<commit_message>
Localize code review materials to Chinese
</commit_message>
<xml_diff>
--- a/docs/code_review_meeting_2026_05_07.pptx
+++ b/docs/code_review_meeting_2026_05_07.pptx
@@ -2421,7 +2421,7 @@
                 <a:ea typeface="Microsoft YaHei" pitchFamily="34" charset="-122"/>
                 <a:cs typeface="Microsoft YaHei" pitchFamily="34" charset="-120"/>
               </a:rPr>
-              <a:t>Code Review &amp; Model Review</a:t>
+              <a:t>代码审查与模型复盘</a:t>
             </a:r>
             <a:endParaRPr lang="en-US" sz="3400" dirty="0"/>
           </a:p>
@@ -2542,7 +2542,7 @@
                 <a:ea typeface="Microsoft YaHei" pitchFamily="34" charset="-122"/>
                 <a:cs typeface="Microsoft YaHei" pitchFamily="34" charset="-120"/>
               </a:rPr>
-              <a:t>A-stage replay after fixing latest inference</a:t>
+              <a:t>修复 latest inference 后的 A-stage replay</a:t>
             </a:r>
             <a:endParaRPr lang="en-US" sz="850" dirty="0"/>
           </a:p>
@@ -2665,7 +2665,7 @@
                 <a:ea typeface="Microsoft YaHei" pitchFamily="34" charset="-122"/>
                 <a:cs typeface="Microsoft YaHei" pitchFamily="34" charset="-120"/>
               </a:rPr>
-              <a:t>Original public score</a:t>
+              <a:t>原始公开成绩</a:t>
             </a:r>
             <a:endParaRPr lang="en-US" sz="850" dirty="0"/>
           </a:p>
@@ -2706,7 +2706,7 @@
                 <a:ea typeface="Microsoft YaHei" pitchFamily="34" charset="-122"/>
                 <a:cs typeface="Microsoft YaHei" pitchFamily="34" charset="-120"/>
               </a:rPr>
-              <a:t>date-aligned replay gap</a:t>
+              <a:t>日期对齐差距</a:t>
             </a:r>
             <a:endParaRPr lang="en-US" sz="800" dirty="0"/>
           </a:p>
@@ -2788,7 +2788,7 @@
                 <a:ea typeface="Microsoft YaHei" pitchFamily="34" charset="-122"/>
                 <a:cs typeface="Microsoft YaHei" pitchFamily="34" charset="-120"/>
               </a:rPr>
-              <a:t>Current production result</a:t>
+              <a:t>当前生产结果</a:t>
             </a:r>
             <a:endParaRPr lang="en-US" sz="850" dirty="0"/>
           </a:p>
@@ -2939,7 +2939,7 @@
                 <a:ea typeface="Microsoft YaHei" pitchFamily="34" charset="-122"/>
                 <a:cs typeface="Microsoft YaHei" pitchFamily="34" charset="-120"/>
               </a:rPr>
-              <a:t>CODE REVIEW MAP</a:t>
+              <a:t>代码地图</a:t>
             </a:r>
             <a:endParaRPr lang="en-US" sz="800" dirty="0"/>
           </a:p>
@@ -3039,7 +3039,7 @@
                   <a:srgbClr val="94A3B8"/>
                 </a:solidFill>
               </a:rPr>
-              <a:t>2026-05-07 · CSI300 Competition Review</a:t>
+              <a:t>2026-05-07 · CSI300 比赛复盘</a:t>
             </a:r>
             <a:endParaRPr lang="en-US" sz="750" dirty="0"/>
           </a:p>
@@ -3090,7 +3090,7 @@
                           <a:ea typeface="Microsoft YaHei" pitchFamily="34" charset="-122"/>
                           <a:cs typeface="Microsoft YaHei" pitchFamily="34" charset="-120"/>
                         </a:rPr>
-                        <a:t>Area</a:t>
+                        <a:t>模块</a:t>
                       </a:r>
                       <a:endParaRPr lang="en-US" sz="820" dirty="0">
                         <a:latin typeface="Microsoft YaHei" charset="0"/>
@@ -3158,7 +3158,7 @@
                           <a:ea typeface="Microsoft YaHei" pitchFamily="34" charset="-122"/>
                           <a:cs typeface="Microsoft YaHei" pitchFamily="34" charset="-120"/>
                         </a:rPr>
-                        <a:t>Files</a:t>
+                        <a:t>文件</a:t>
                       </a:r>
                       <a:endParaRPr lang="en-US" sz="820" dirty="0">
                         <a:latin typeface="Microsoft YaHei" charset="0"/>
@@ -3226,7 +3226,7 @@
                           <a:ea typeface="Microsoft YaHei" pitchFamily="34" charset="-122"/>
                           <a:cs typeface="Microsoft YaHei" pitchFamily="34" charset="-120"/>
                         </a:rPr>
-                        <a:t>Review question</a:t>
+                        <a:t>审查问题</a:t>
                       </a:r>
                       <a:endParaRPr lang="en-US" sz="820" dirty="0">
                         <a:latin typeface="Microsoft YaHei" charset="0"/>
@@ -4204,7 +4204,7 @@
                 <a:ea typeface="Microsoft YaHei" pitchFamily="34" charset="-122"/>
                 <a:cs typeface="Microsoft YaHei" pitchFamily="34" charset="-120"/>
               </a:rPr>
-              <a:t>Meeting decision</a:t>
+              <a:t>会议决策</a:t>
             </a:r>
             <a:endParaRPr lang="en-US" sz="1050" dirty="0"/>
           </a:p>
@@ -4416,7 +4416,7 @@
                   <a:srgbClr val="94A3B8"/>
                 </a:solidFill>
               </a:rPr>
-              <a:t>2026-05-07 · CSI300 Competition Review</a:t>
+              <a:t>2026-05-07 · CSI300 比赛复盘</a:t>
             </a:r>
             <a:endParaRPr lang="en-US" sz="750" dirty="0"/>
           </a:p>
@@ -4564,7 +4564,7 @@
                 <a:ea typeface="Microsoft YaHei" pitchFamily="34" charset="-122"/>
                 <a:cs typeface="Microsoft YaHei" pitchFamily="34" charset="-120"/>
               </a:rPr>
-              <a:t>Next experiments</a:t>
+              <a:t>下一批实验</a:t>
             </a:r>
             <a:endParaRPr lang="en-US" sz="1300" dirty="0"/>
           </a:p>
@@ -4671,7 +4671,7 @@
                 <a:ea typeface="Microsoft YaHei" pitchFamily="34" charset="-122"/>
                 <a:cs typeface="Microsoft YaHei" pitchFamily="34" charset="-120"/>
               </a:rPr>
-              <a:t>Longer term</a:t>
+              <a:t>长期方向</a:t>
             </a:r>
             <a:endParaRPr lang="en-US" sz="1300" dirty="0"/>
           </a:p>
@@ -4801,7 +4801,7 @@
                 <a:ea typeface="Microsoft YaHei" pitchFamily="34" charset="-122"/>
                 <a:cs typeface="Microsoft YaHei" pitchFamily="34" charset="-120"/>
               </a:rPr>
-              <a:t>North star</a:t>
+              <a:t>核心准则</a:t>
             </a:r>
             <a:endParaRPr lang="en-US" sz="1050" dirty="0"/>
           </a:p>
@@ -4913,7 +4913,7 @@
                 <a:ea typeface="Microsoft YaHei" pitchFamily="34" charset="-122"/>
                 <a:cs typeface="Microsoft YaHei" pitchFamily="34" charset="-120"/>
               </a:rPr>
-              <a:t>SOURCE APPENDIX</a:t>
+              <a:t>源码附录</a:t>
             </a:r>
             <a:endParaRPr lang="en-US" sz="800" dirty="0"/>
           </a:p>
@@ -4954,7 +4954,7 @@
                 <a:ea typeface="Microsoft YaHei" pitchFamily="34" charset="-122"/>
                 <a:cs typeface="Microsoft YaHei" pitchFamily="34" charset="-120"/>
               </a:rPr>
-              <a:t>Code review priorities: inspect by failure impact</a:t>
+              <a:t>代码审查优先级：按失败影响排序</a:t>
             </a:r>
             <a:endParaRPr lang="en-US" sz="2400" dirty="0"/>
           </a:p>
@@ -5013,7 +5013,7 @@
                   <a:srgbClr val="94A3B8"/>
                 </a:solidFill>
               </a:rPr>
-              <a:t>2026-05-07 · CSI300 Competition Review</a:t>
+              <a:t>2026-05-07 · CSI300 比赛复盘</a:t>
             </a:r>
             <a:endParaRPr lang="en-US" sz="750" dirty="0"/>
           </a:p>
@@ -5065,7 +5065,7 @@
                           <a:ea typeface="Microsoft YaHei" pitchFamily="34" charset="-122"/>
                           <a:cs typeface="Microsoft YaHei" pitchFamily="34" charset="-120"/>
                         </a:rPr>
-                        <a:t>Priority</a:t>
+                        <a:t>优先级</a:t>
                       </a:r>
                       <a:endParaRPr lang="en-US" sz="820" dirty="0">
                         <a:latin typeface="Microsoft YaHei" charset="0"/>
@@ -5133,7 +5133,7 @@
                           <a:ea typeface="Microsoft YaHei" pitchFamily="34" charset="-122"/>
                           <a:cs typeface="Microsoft YaHei" pitchFamily="34" charset="-120"/>
                         </a:rPr>
-                        <a:t>Area</a:t>
+                        <a:t>审查区域</a:t>
                       </a:r>
                       <a:endParaRPr lang="en-US" sz="820" dirty="0">
                         <a:latin typeface="Microsoft YaHei" charset="0"/>
@@ -5201,7 +5201,7 @@
                           <a:ea typeface="Microsoft YaHei" pitchFamily="34" charset="-122"/>
                           <a:cs typeface="Microsoft YaHei" pitchFamily="34" charset="-120"/>
                         </a:rPr>
-                        <a:t>Source files</a:t>
+                        <a:t>源码文件</a:t>
                       </a:r>
                       <a:endParaRPr lang="en-US" sz="820" dirty="0">
                         <a:latin typeface="Microsoft YaHei" charset="0"/>
@@ -5269,7 +5269,7 @@
                           <a:ea typeface="Microsoft YaHei" pitchFamily="34" charset="-122"/>
                           <a:cs typeface="Microsoft YaHei" pitchFamily="34" charset="-120"/>
                         </a:rPr>
-                        <a:t>Meeting question</a:t>
+                        <a:t>会议问题</a:t>
                       </a:r>
                       <a:endParaRPr lang="en-US" sz="820" dirty="0">
                         <a:latin typeface="Microsoft YaHei" charset="0"/>
@@ -5564,7 +5564,7 @@
                           <a:ea typeface="Microsoft YaHei" pitchFamily="34" charset="-122"/>
                           <a:cs typeface="Microsoft YaHei" pitchFamily="34" charset="-120"/>
                         </a:rPr>
-                        <a:t>Can result.csv ever be generated from the last labeled validation day again?</a:t>
+                        <a:t>result.csv 是否还可能来自最后一个有 label 验证日？</a:t>
                       </a:r>
                       <a:endParaRPr lang="en-US" sz="820" dirty="0">
                         <a:latin typeface="Microsoft YaHei" charset="0"/>
@@ -5838,7 +5838,7 @@
                           <a:ea typeface="Microsoft YaHei" pitchFamily="34" charset="-122"/>
                           <a:cs typeface="Microsoft YaHei" pitchFamily="34" charset="-120"/>
                         </a:rPr>
-                        <a:t>When should Top1 be allowed, capped, or downgraded to Top2/confidence?</a:t>
+                        <a:t>什么时候允许 Top1，什么时候 cap 或降级到 Top2/confidence？</a:t>
                       </a:r>
                       <a:endParaRPr lang="en-US" sz="820" dirty="0">
                         <a:latin typeface="Microsoft YaHei" charset="0"/>
@@ -6133,7 +6133,7 @@
                           <a:ea typeface="Microsoft YaHei" pitchFamily="34" charset="-122"/>
                           <a:cs typeface="Microsoft YaHei" pitchFamily="34" charset="-120"/>
                         </a:rPr>
-                        <a:t>Are parameters selected only from information available before T?</a:t>
+                        <a:t>参数是否只用 T 之前可见的信息选择？</a:t>
                       </a:r>
                       <a:endParaRPr lang="en-US" sz="820" dirty="0">
                         <a:latin typeface="Microsoft YaHei" charset="0"/>
@@ -6407,7 +6407,7 @@
                           <a:ea typeface="Microsoft YaHei" pitchFamily="34" charset="-122"/>
                           <a:cs typeface="Microsoft YaHei" pitchFamily="34" charset="-120"/>
                         </a:rPr>
-                        <a:t>How do we align loss with final portfolio return without chasing noisy extremes?</a:t>
+                        <a:t>如何让 loss 对齐最终组合收益，同时不追极端噪声？</a:t>
                       </a:r>
                       <a:endParaRPr lang="en-US" sz="820" dirty="0">
                         <a:latin typeface="Microsoft YaHei" charset="0"/>
@@ -6545,7 +6545,7 @@
                           <a:ea typeface="Microsoft YaHei" pitchFamily="34" charset="-122"/>
                           <a:cs typeface="Microsoft YaHei" pitchFamily="34" charset="-120"/>
                         </a:rPr>
-                        <a:t>Data engineering</a:t>
+                        <a:t>数据工程</a:t>
                       </a:r>
                       <a:endParaRPr lang="en-US" sz="820" dirty="0">
                         <a:latin typeface="Microsoft YaHei" charset="0"/>
@@ -6702,7 +6702,7 @@
                           <a:ea typeface="Microsoft YaHei" pitchFamily="34" charset="-122"/>
                           <a:cs typeface="Microsoft YaHei" pitchFamily="34" charset="-120"/>
                         </a:rPr>
-                        <a:t>Which columns are guaranteed, optional, or cached from previous processed artifacts?</a:t>
+                        <a:t>哪些列是 guaranteed、optional，哪些来自 cached artifact？</a:t>
                       </a:r>
                       <a:endParaRPr lang="en-US" sz="820" dirty="0">
                         <a:latin typeface="Microsoft YaHei" charset="0"/>
@@ -6793,7 +6793,7 @@
                 <a:ea typeface="Microsoft YaHei" pitchFamily="34" charset="-122"/>
                 <a:cs typeface="Microsoft YaHei" pitchFamily="34" charset="-120"/>
               </a:rPr>
-              <a:t>Review stance: protect online correctness first; increase modeling complexity only after the submission loop is reproducible.</a:t>
+              <a:t>审查立场：先保护线上正确性；只有提交闭环可复现之后，再增加模型复杂度。</a:t>
             </a:r>
             <a:endParaRPr lang="en-US" sz="1300" dirty="0"/>
           </a:p>
@@ -6864,7 +6864,7 @@
                 <a:ea typeface="Microsoft YaHei" pitchFamily="34" charset="-122"/>
                 <a:cs typeface="Microsoft YaHei" pitchFamily="34" charset="-120"/>
               </a:rPr>
-              <a:t>SOURCE APPENDIX</a:t>
+              <a:t>源码附录</a:t>
             </a:r>
             <a:endParaRPr lang="en-US" sz="800" dirty="0"/>
           </a:p>
@@ -6905,7 +6905,7 @@
                 <a:ea typeface="Microsoft YaHei" pitchFamily="34" charset="-122"/>
                 <a:cs typeface="Microsoft YaHei" pitchFamily="34" charset="-120"/>
               </a:rPr>
-              <a:t>P0 source: latest T-date inference</a:t>
+              <a:t>P0 源码：latest T-date inference</a:t>
             </a:r>
             <a:endParaRPr lang="en-US" sz="2400" dirty="0"/>
           </a:p>
@@ -6964,7 +6964,7 @@
                   <a:srgbClr val="94A3B8"/>
                 </a:solidFill>
               </a:rPr>
-              <a:t>2026-05-07 · CSI300 Competition Review</a:t>
+              <a:t>2026-05-07 · CSI300 比赛复盘</a:t>
             </a:r>
             <a:endParaRPr lang="en-US" sz="750" dirty="0"/>
           </a:p>
@@ -7124,7 +7124,7 @@
                 <a:ea typeface="Microsoft YaHei" pitchFamily="34" charset="-122"/>
                 <a:cs typeface="Microsoft YaHei" pitchFamily="34" charset="-120"/>
               </a:rPr>
-              <a:t>labeled train</a:t>
+              <a:t>有 label 训练</a:t>
             </a:r>
             <a:endParaRPr lang="en-US" sz="750" dirty="0"/>
           </a:p>
@@ -7216,7 +7216,7 @@
                 <a:ea typeface="Microsoft YaHei" pitchFamily="34" charset="-122"/>
                 <a:cs typeface="Microsoft YaHei" pitchFamily="34" charset="-120"/>
               </a:rPr>
-              <a:t>unlabeled T</a:t>
+              <a:t>无 label T</a:t>
             </a:r>
             <a:endParaRPr lang="en-US" sz="750" dirty="0"/>
           </a:p>
@@ -7974,7 +7974,7 @@
                 <a:ea typeface="Microsoft YaHei" pitchFamily="34" charset="-122"/>
                 <a:cs typeface="Microsoft YaHei" pitchFamily="34" charset="-120"/>
               </a:rPr>
-              <a:t>Must assert latest_pred.date == configured T before submission</a:t>
+              <a:t>提交前必须断言 latest_pred.date == configured T</a:t>
             </a:r>
             <a:endParaRPr lang="en-US" sz="800" dirty="0"/>
           </a:p>
@@ -8045,7 +8045,7 @@
                 <a:ea typeface="Microsoft YaHei" pitchFamily="34" charset="-122"/>
                 <a:cs typeface="Microsoft YaHei" pitchFamily="34" charset="-120"/>
               </a:rPr>
-              <a:t>SOURCE APPENDIX</a:t>
+              <a:t>源码附录</a:t>
             </a:r>
             <a:endParaRPr lang="en-US" sz="800" dirty="0"/>
           </a:p>
@@ -8086,7 +8086,7 @@
                 <a:ea typeface="Microsoft YaHei" pitchFamily="34" charset="-122"/>
                 <a:cs typeface="Microsoft YaHei" pitchFamily="34" charset="-120"/>
               </a:rPr>
-              <a:t>P1 source: confidence-aware portfolio allocation</a:t>
+              <a:t>P1 源码：confidence-aware portfolio allocation</a:t>
             </a:r>
             <a:endParaRPr lang="en-US" sz="2400" dirty="0"/>
           </a:p>
@@ -8145,7 +8145,7 @@
                   <a:srgbClr val="94A3B8"/>
                 </a:solidFill>
               </a:rPr>
-              <a:t>2026-05-07 · CSI300 Competition Review</a:t>
+              <a:t>2026-05-07 · CSI300 比赛复盘</a:t>
             </a:r>
             <a:endParaRPr lang="en-US" sz="750" dirty="0"/>
           </a:p>
@@ -8909,7 +8909,7 @@
                 <a:ea typeface="Microsoft YaHei" pitchFamily="34" charset="-122"/>
                 <a:cs typeface="Microsoft YaHei" pitchFamily="34" charset="-120"/>
               </a:rPr>
-              <a:t>Review decisions</a:t>
+              <a:t>审查决策</a:t>
             </a:r>
             <a:endParaRPr lang="en-US" sz="1300" dirty="0"/>
           </a:p>
@@ -8947,7 +8947,7 @@
                 <a:ea typeface="Microsoft YaHei" pitchFamily="34" charset="-122"/>
                 <a:cs typeface="Microsoft YaHei" pitchFamily="34" charset="-120"/>
               </a:rPr>
-              <a:t>Production default: top1, top2, or confidence?</a:t>
+              <a:t>生产默认：top1、top2 还是 confidence？</a:t>
             </a:r>
             <a:endParaRPr lang="en-US" sz="1100" dirty="0"/>
           </a:p>
@@ -8961,7 +8961,7 @@
                 <a:ea typeface="Microsoft YaHei" pitchFamily="34" charset="-122"/>
                 <a:cs typeface="Microsoft YaHei" pitchFamily="34" charset="-120"/>
               </a:rPr>
-              <a:t>Should multi-seed score_std cap single-stock weight?</a:t>
+              <a:t>multi-seed 的 score_std 是否限制单股权重？</a:t>
             </a:r>
             <a:endParaRPr lang="en-US" sz="1100" dirty="0"/>
           </a:p>
@@ -8975,7 +8975,7 @@
                 <a:ea typeface="Microsoft YaHei" pitchFamily="34" charset="-122"/>
                 <a:cs typeface="Microsoft YaHei" pitchFamily="34" charset="-120"/>
               </a:rPr>
-              <a:t>Do we need our own max single-stock cap?</a:t>
+              <a:t>是否需要内部 max single-stock cap？</a:t>
             </a:r>
             <a:endParaRPr lang="en-US" sz="1100" dirty="0"/>
           </a:p>
@@ -8989,7 +8989,7 @@
                 <a:ea typeface="Microsoft YaHei" pitchFamily="34" charset="-122"/>
                 <a:cs typeface="Microsoft YaHei" pitchFamily="34" charset="-120"/>
               </a:rPr>
-              <a:t>Should each result save margin/std/fallback reason?</a:t>
+              <a:t>每次 result 是否保存 margin/std/fallback reason？</a:t>
             </a:r>
             <a:endParaRPr lang="en-US" sz="1100" dirty="0"/>
           </a:p>
@@ -9224,7 +9224,7 @@
                 <a:ea typeface="Microsoft YaHei" pitchFamily="34" charset="-122"/>
                 <a:cs typeface="Microsoft YaHei" pitchFamily="34" charset="-120"/>
               </a:rPr>
-              <a:t>SOURCE APPENDIX</a:t>
+              <a:t>源码附录</a:t>
             </a:r>
             <a:endParaRPr lang="en-US" sz="800" dirty="0"/>
           </a:p>
@@ -9265,7 +9265,7 @@
                 <a:ea typeface="Microsoft YaHei" pitchFamily="34" charset="-122"/>
                 <a:cs typeface="Microsoft YaHei" pitchFamily="34" charset="-120"/>
               </a:rPr>
-              <a:t>P1 source: walk-forward validation loop</a:t>
+              <a:t>P1 源码：walk-forward validation loop</a:t>
             </a:r>
             <a:endParaRPr lang="en-US" sz="2400" dirty="0"/>
           </a:p>
@@ -9324,7 +9324,7 @@
                   <a:srgbClr val="94A3B8"/>
                 </a:solidFill>
               </a:rPr>
-              <a:t>2026-05-07 · CSI300 Competition Review</a:t>
+              <a:t>2026-05-07 · CSI300 比赛复盘</a:t>
             </a:r>
             <a:endParaRPr lang="en-US" sz="750" dirty="0"/>
           </a:p>
@@ -9392,7 +9392,7 @@
                 <a:ea typeface="Microsoft YaHei" pitchFamily="34" charset="-122"/>
                 <a:cs typeface="Microsoft YaHei" pitchFamily="34" charset="-120"/>
               </a:rPr>
-              <a:t>history before T</a:t>
+              <a:t>T 前历史</a:t>
             </a:r>
             <a:endParaRPr lang="en-US" sz="750" dirty="0"/>
           </a:p>
@@ -9484,7 +9484,7 @@
                 <a:ea typeface="Microsoft YaHei" pitchFamily="34" charset="-122"/>
                 <a:cs typeface="Microsoft YaHei" pitchFamily="34" charset="-120"/>
               </a:rPr>
-              <a:t>select params</a:t>
+              <a:t>选择参数</a:t>
             </a:r>
             <a:endParaRPr lang="en-US" sz="750" dirty="0"/>
           </a:p>
@@ -9576,7 +9576,7 @@
                 <a:ea typeface="Microsoft YaHei" pitchFamily="34" charset="-122"/>
                 <a:cs typeface="Microsoft YaHei" pitchFamily="34" charset="-120"/>
               </a:rPr>
-              <a:t>build portfolio</a:t>
+              <a:t>构造组合</a:t>
             </a:r>
             <a:endParaRPr lang="en-US" sz="750" dirty="0"/>
           </a:p>
@@ -9668,7 +9668,7 @@
                 <a:ea typeface="Microsoft YaHei" pitchFamily="34" charset="-122"/>
                 <a:cs typeface="Microsoft YaHei" pitchFamily="34" charset="-120"/>
               </a:rPr>
-              <a:t>score T+1:T+5</a:t>
+              <a:t>评分 T+1:T+5</a:t>
             </a:r>
             <a:endParaRPr lang="en-US" sz="750" dirty="0"/>
           </a:p>
@@ -9760,7 +9760,7 @@
                 <a:ea typeface="Microsoft YaHei" pitchFamily="34" charset="-122"/>
                 <a:cs typeface="Microsoft YaHei" pitchFamily="34" charset="-120"/>
               </a:rPr>
-              <a:t>advance T</a:t>
+              <a:t>推进 T</a:t>
             </a:r>
             <a:endParaRPr lang="en-US" sz="750" dirty="0"/>
           </a:p>
@@ -10273,7 +10273,7 @@
                 <a:ea typeface="Microsoft YaHei" pitchFamily="34" charset="-122"/>
                 <a:cs typeface="Microsoft YaHei" pitchFamily="34" charset="-120"/>
               </a:rPr>
-              <a:t>Audit rule: no parameter can be chosen using data after the simulated submission date T.</a:t>
+              <a:t>审查规则：任何参数都不能使用模拟提交日 T 之后的数据选择。</a:t>
             </a:r>
             <a:endParaRPr lang="en-US" sz="1300" dirty="0"/>
           </a:p>
@@ -10344,7 +10344,7 @@
                 <a:ea typeface="Microsoft YaHei" pitchFamily="34" charset="-122"/>
                 <a:cs typeface="Microsoft YaHei" pitchFamily="34" charset="-120"/>
               </a:rPr>
-              <a:t>DATA ENGINEERING</a:t>
+              <a:t>数据工程</a:t>
             </a:r>
             <a:endParaRPr lang="en-US" sz="800" dirty="0"/>
           </a:p>
@@ -10385,7 +10385,7 @@
                 <a:ea typeface="Microsoft YaHei" pitchFamily="34" charset="-122"/>
                 <a:cs typeface="Microsoft YaHei" pitchFamily="34" charset="-120"/>
               </a:rPr>
-              <a:t>P2 data engineering: raw row to model row</a:t>
+              <a:t>P2 数据工程：raw row 到 model row</a:t>
             </a:r>
             <a:endParaRPr lang="en-US" sz="2400" dirty="0"/>
           </a:p>
@@ -10444,7 +10444,7 @@
                   <a:srgbClr val="94A3B8"/>
                 </a:solidFill>
               </a:rPr>
-              <a:t>2026-05-07 · CSI300 Competition Review</a:t>
+              <a:t>2026-05-07 · CSI300 比赛复盘</a:t>
             </a:r>
             <a:endParaRPr lang="en-US" sz="750" dirty="0"/>
           </a:p>
@@ -10931,7 +10931,7 @@
                           <a:ea typeface="Microsoft YaHei" pitchFamily="34" charset="-122"/>
                           <a:cs typeface="Microsoft YaHei" pitchFamily="34" charset="-120"/>
                         </a:rPr>
-                        <a:t>Stage</a:t>
+                        <a:t>阶段</a:t>
                       </a:r>
                       <a:endParaRPr lang="en-US" sz="820" dirty="0">
                         <a:latin typeface="Microsoft YaHei" charset="0"/>
@@ -10999,7 +10999,7 @@
                           <a:ea typeface="Microsoft YaHei" pitchFamily="34" charset="-122"/>
                           <a:cs typeface="Microsoft YaHei" pitchFamily="34" charset="-120"/>
                         </a:rPr>
-                        <a:t>Example</a:t>
+                        <a:t>样例</a:t>
                       </a:r>
                       <a:endParaRPr lang="en-US" sz="820" dirty="0">
                         <a:latin typeface="Microsoft YaHei" charset="0"/>
@@ -11067,7 +11067,7 @@
                           <a:ea typeface="Microsoft YaHei" pitchFamily="34" charset="-122"/>
                           <a:cs typeface="Microsoft YaHei" pitchFamily="34" charset="-120"/>
                         </a:rPr>
-                        <a:t>Audit check</a:t>
+                        <a:t>审计点</a:t>
                       </a:r>
                       <a:endParaRPr lang="en-US" sz="820" dirty="0">
                         <a:latin typeface="Microsoft YaHei" charset="0"/>
@@ -11273,7 +11273,7 @@
                           <a:ea typeface="Microsoft YaHei" pitchFamily="34" charset="-122"/>
                           <a:cs typeface="Microsoft YaHei" pitchFamily="34" charset="-120"/>
                         </a:rPr>
-                        <a:t>stock_id must remain zero-padded text</a:t>
+                        <a:t>stock_id 必须保持 zero-padded text</a:t>
                       </a:r>
                       <a:endParaRPr lang="en-US" sz="820" dirty="0">
                         <a:latin typeface="Microsoft YaHei" charset="0"/>
@@ -11479,7 +11479,7 @@
                           <a:ea typeface="Microsoft YaHei" pitchFamily="34" charset="-122"/>
                           <a:cs typeface="Microsoft YaHei" pitchFamily="34" charset="-120"/>
                         </a:rPr>
-                        <a:t>no future shift except explicit label columns</a:t>
+                        <a:t>除显式 label 列外不能 future shift</a:t>
                       </a:r>
                       <a:endParaRPr lang="en-US" sz="820" dirty="0">
                         <a:latin typeface="Microsoft YaHei" charset="0"/>
@@ -11617,7 +11617,7 @@
                           <a:ea typeface="Microsoft YaHei" pitchFamily="34" charset="-122"/>
                           <a:cs typeface="Microsoft YaHei" pitchFamily="34" charset="-120"/>
                         </a:rPr>
-                        <a:t>2026-04-24 rows have blank future label</a:t>
+                        <a:t>2026-04-24 rows 的未来 label 为空</a:t>
                       </a:r>
                       <a:endParaRPr lang="en-US" sz="820" dirty="0">
                         <a:latin typeface="Microsoft YaHei" charset="0"/>
@@ -11685,7 +11685,7 @@
                           <a:ea typeface="Microsoft YaHei" pitchFamily="34" charset="-122"/>
                           <a:cs typeface="Microsoft YaHei" pitchFamily="34" charset="-120"/>
                         </a:rPr>
-                        <a:t>features up to T only</a:t>
+                        <a:t>features 只能到 T</a:t>
                       </a:r>
                       <a:endParaRPr lang="en-US" sz="820" dirty="0">
                         <a:latin typeface="Microsoft YaHei" charset="0"/>
@@ -11823,7 +11823,7 @@
                           <a:ea typeface="Microsoft YaHei" pitchFamily="34" charset="-122"/>
                           <a:cs typeface="Microsoft YaHei" pitchFamily="34" charset="-120"/>
                         </a:rPr>
-                        <a:t>T+1 open to T+5 open return after phase</a:t>
+                        <a:t>阶段结束后计算 T+1 open 到 T+5 open return</a:t>
                       </a:r>
                       <a:endParaRPr lang="en-US" sz="820" dirty="0">
                         <a:latin typeface="Microsoft YaHei" charset="0"/>
@@ -11891,7 +11891,7 @@
                           <a:ea typeface="Microsoft YaHei" pitchFamily="34" charset="-122"/>
                           <a:cs typeface="Microsoft YaHei" pitchFamily="34" charset="-120"/>
                         </a:rPr>
-                        <a:t>used only for post-submit evaluation</a:t>
+                        <a:t>只用于赛后评估</a:t>
                       </a:r>
                       <a:endParaRPr lang="en-US" sz="820" dirty="0">
                         <a:latin typeface="Microsoft YaHei" charset="0"/>
@@ -12034,7 +12034,7 @@
                 <a:ea typeface="Microsoft YaHei" pitchFamily="34" charset="-122"/>
                 <a:cs typeface="Microsoft YaHei" pitchFamily="34" charset="-120"/>
               </a:rPr>
-              <a:t>sample processed T rows</a:t>
+              <a:t>processed T rows 样例</a:t>
             </a:r>
             <a:endParaRPr lang="en-US" sz="750" dirty="0"/>
           </a:p>
@@ -12167,7 +12167,7 @@
                 <a:ea typeface="Microsoft YaHei" pitchFamily="34" charset="-122"/>
                 <a:cs typeface="Microsoft YaHei" pitchFamily="34" charset="-120"/>
               </a:rPr>
-              <a:t>Caveat: theme/momentum code can exist while the cached processed artifact still needs a rebuild before those columns appear.</a:t>
+              <a:t>Caveat：theme/momentum 代码存在，不代表 cached processed artifact 已重建出这些列。</a:t>
             </a:r>
             <a:endParaRPr lang="en-US" sz="1000" dirty="0"/>
           </a:p>
@@ -12238,7 +12238,7 @@
                 <a:ea typeface="Microsoft YaHei" pitchFamily="34" charset="-122"/>
                 <a:cs typeface="Microsoft YaHei" pitchFamily="34" charset="-120"/>
               </a:rPr>
-              <a:t>SOURCE APPENDIX</a:t>
+              <a:t>源码附录</a:t>
             </a:r>
             <a:endParaRPr lang="en-US" sz="800" dirty="0"/>
           </a:p>
@@ -12279,7 +12279,7 @@
                 <a:ea typeface="Microsoft YaHei" pitchFamily="34" charset="-122"/>
                 <a:cs typeface="Microsoft YaHei" pitchFamily="34" charset="-120"/>
               </a:rPr>
-              <a:t>P2 source: portfolio-return objective</a:t>
+              <a:t>P2 源码：portfolio-return objective</a:t>
             </a:r>
             <a:endParaRPr lang="en-US" sz="2400" dirty="0"/>
           </a:p>
@@ -12338,7 +12338,7 @@
                   <a:srgbClr val="94A3B8"/>
                 </a:solidFill>
               </a:rPr>
-              <a:t>2026-05-07 · CSI300 Competition Review</a:t>
+              <a:t>2026-05-07 · CSI300 比赛复盘</a:t>
             </a:r>
             <a:endParaRPr lang="en-US" sz="750" dirty="0"/>
           </a:p>
@@ -13068,7 +13068,7 @@
                 <a:ea typeface="Microsoft YaHei" pitchFamily="34" charset="-122"/>
                 <a:cs typeface="Microsoft YaHei" pitchFamily="34" charset="-120"/>
               </a:rPr>
-              <a:t>Why v1 failed</a:t>
+              <a:t>v1 失败原因</a:t>
             </a:r>
             <a:endParaRPr lang="en-US" sz="1300" dirty="0"/>
           </a:p>
@@ -13106,7 +13106,7 @@
                 <a:ea typeface="Microsoft YaHei" pitchFamily="34" charset="-122"/>
                 <a:cs typeface="Microsoft YaHei" pitchFamily="34" charset="-120"/>
               </a:rPr>
-              <a:t>Head labels are noisy and extreme.</a:t>
+              <a:t>头部 label 噪声和极端值很强。</a:t>
             </a:r>
             <a:endParaRPr lang="en-US" sz="1100" dirty="0"/>
           </a:p>
@@ -13120,7 +13120,7 @@
                 <a:ea typeface="Microsoft YaHei" pitchFamily="34" charset="-122"/>
                 <a:cs typeface="Microsoft YaHei" pitchFamily="34" charset="-120"/>
               </a:rPr>
-              <a:t>Softmax can overreact to small score gaps.</a:t>
+              <a:t>Softmax 容易对很小的 score gap 过度反应。</a:t>
             </a:r>
             <a:endParaRPr lang="en-US" sz="1100" dirty="0"/>
           </a:p>
@@ -13134,7 +13134,7 @@
                 <a:ea typeface="Microsoft YaHei" pitchFamily="34" charset="-122"/>
                 <a:cs typeface="Microsoft YaHei" pitchFamily="34" charset="-120"/>
               </a:rPr>
-              <a:t>Direct loss underperformed official MASTER in replay.</a:t>
+              <a:t>Direct loss 在 replay 中弱于 official MASTER。</a:t>
             </a:r>
             <a:endParaRPr lang="en-US" sz="1100" dirty="0"/>
           </a:p>
@@ -13148,7 +13148,7 @@
                 <a:ea typeface="Microsoft YaHei" pitchFamily="34" charset="-122"/>
                 <a:cs typeface="Microsoft YaHei" pitchFamily="34" charset="-120"/>
               </a:rPr>
-              <a:t>Next version should add capped labels, downside penalty, multi-seed smoothing, and late-stage blending.</a:t>
+              <a:t>下一版需要 capped labels、downside penalty、multi-seed smoothing 和 late-stage blending。</a:t>
             </a:r>
             <a:endParaRPr lang="en-US" sz="1100" dirty="0"/>
           </a:p>
@@ -13189,7 +13189,7 @@
                 <a:ea typeface="Microsoft YaHei" pitchFamily="34" charset="-122"/>
                 <a:cs typeface="Microsoft YaHei" pitchFamily="34" charset="-120"/>
               </a:rPr>
-              <a:t>This is an experiment track, not a production replacement yet.</a:t>
+              <a:t>这是实验方向，还不是生产替代方案。</a:t>
             </a:r>
             <a:endParaRPr lang="en-US" sz="1400" dirty="0"/>
           </a:p>
@@ -13360,7 +13360,7 @@
                   <a:srgbClr val="94A3B8"/>
                 </a:solidFill>
               </a:rPr>
-              <a:t>2026-05-07 · CSI300 Competition Review</a:t>
+              <a:t>2026-05-07 · CSI300 比赛复盘</a:t>
             </a:r>
             <a:endParaRPr lang="en-US" sz="750" dirty="0"/>
           </a:p>
@@ -13563,7 +13563,7 @@
                 <a:ea typeface="Microsoft YaHei" pitchFamily="34" charset="-122"/>
                 <a:cs typeface="Microsoft YaHei" pitchFamily="34" charset="-120"/>
               </a:rPr>
-              <a:t>best replay score</a:t>
+              <a:t>最佳 replay 分数</a:t>
             </a:r>
             <a:endParaRPr lang="en-US" sz="850" dirty="0"/>
           </a:p>
@@ -13645,7 +13645,7 @@
                 <a:ea typeface="Microsoft YaHei" pitchFamily="34" charset="-122"/>
                 <a:cs typeface="Microsoft YaHei" pitchFamily="34" charset="-120"/>
               </a:rPr>
-              <a:t>Top1 validation std</a:t>
+              <a:t>Top1 验证 std</a:t>
             </a:r>
             <a:endParaRPr lang="en-US" sz="850" dirty="0"/>
           </a:p>
@@ -13727,7 +13727,7 @@
                 <a:ea typeface="Microsoft YaHei" pitchFamily="34" charset="-122"/>
                 <a:cs typeface="Microsoft YaHei" pitchFamily="34" charset="-120"/>
               </a:rPr>
-              <a:t>processed features</a:t>
+              <a:t>processed 特征数</a:t>
             </a:r>
             <a:endParaRPr lang="en-US" sz="850" dirty="0"/>
           </a:p>
@@ -13809,7 +13809,7 @@
                 <a:ea typeface="Microsoft YaHei" pitchFamily="34" charset="-122"/>
                 <a:cs typeface="Microsoft YaHei" pitchFamily="34" charset="-120"/>
               </a:rPr>
-              <a:t>stocks</a:t>
+              <a:t>股票数</a:t>
             </a:r>
             <a:endParaRPr lang="en-US" sz="850" dirty="0"/>
           </a:p>
@@ -13980,7 +13980,7 @@
                   <a:srgbClr val="94A3B8"/>
                 </a:solidFill>
               </a:rPr>
-              <a:t>2026-05-07 · CSI300 Competition Review</a:t>
+              <a:t>2026-05-07 · CSI300 比赛复盘</a:t>
             </a:r>
             <a:endParaRPr lang="en-US" sz="750" dirty="0"/>
           </a:p>
@@ -14032,7 +14032,7 @@
                           <a:ea typeface="Microsoft YaHei" pitchFamily="34" charset="-122"/>
                           <a:cs typeface="Microsoft YaHei" pitchFamily="34" charset="-120"/>
                         </a:rPr>
-                        <a:t>Dataset</a:t>
+                        <a:t>数据集</a:t>
                       </a:r>
                       <a:endParaRPr lang="en-US" sz="820" dirty="0">
                         <a:latin typeface="Microsoft YaHei" charset="0"/>
@@ -14100,7 +14100,7 @@
                           <a:ea typeface="Microsoft YaHei" pitchFamily="34" charset="-122"/>
                           <a:cs typeface="Microsoft YaHei" pitchFamily="34" charset="-120"/>
                         </a:rPr>
-                        <a:t>Rows</a:t>
+                        <a:t>行数</a:t>
                       </a:r>
                       <a:endParaRPr lang="en-US" sz="820" dirty="0">
                         <a:latin typeface="Microsoft YaHei" charset="0"/>
@@ -14168,7 +14168,7 @@
                           <a:ea typeface="Microsoft YaHei" pitchFamily="34" charset="-122"/>
                           <a:cs typeface="Microsoft YaHei" pitchFamily="34" charset="-120"/>
                         </a:rPr>
-                        <a:t>Columns</a:t>
+                        <a:t>列数</a:t>
                       </a:r>
                       <a:endParaRPr lang="en-US" sz="820" dirty="0">
                         <a:latin typeface="Microsoft YaHei" charset="0"/>
@@ -14236,7 +14236,7 @@
                           <a:ea typeface="Microsoft YaHei" pitchFamily="34" charset="-122"/>
                           <a:cs typeface="Microsoft YaHei" pitchFamily="34" charset="-120"/>
                         </a:rPr>
-                        <a:t>Coverage</a:t>
+                        <a:t>覆盖范围</a:t>
                       </a:r>
                       <a:endParaRPr lang="en-US" sz="820" dirty="0">
                         <a:latin typeface="Microsoft YaHei" charset="0"/>
@@ -15058,7 +15058,7 @@
                           <a:ea typeface="Microsoft YaHei" pitchFamily="34" charset="-122"/>
                           <a:cs typeface="Microsoft YaHei" pitchFamily="34" charset="-120"/>
                         </a:rPr>
-                        <a:t>component universe</a:t>
+                        <a:t>成分股池</a:t>
                       </a:r>
                       <a:endParaRPr lang="en-US" sz="820" dirty="0">
                         <a:latin typeface="Microsoft YaHei" charset="0"/>
@@ -15645,7 +15645,7 @@
                   <a:srgbClr val="94A3B8"/>
                 </a:solidFill>
               </a:rPr>
-              <a:t>2026-05-07 · CSI300 Competition Review</a:t>
+              <a:t>2026-05-07 · CSI300 比赛复盘</a:t>
             </a:r>
             <a:endParaRPr lang="en-US" sz="750" dirty="0"/>
           </a:p>
@@ -16356,7 +16356,7 @@
                 <a:ea typeface="Microsoft YaHei" pitchFamily="34" charset="-122"/>
                 <a:cs typeface="Microsoft YaHei" pitchFamily="34" charset="-120"/>
               </a:rPr>
-              <a:t>after fixing</a:t>
+              <a:t>修复后</a:t>
             </a:r>
             <a:endParaRPr lang="en-US" sz="850" dirty="0"/>
           </a:p>
@@ -16397,7 +16397,7 @@
                 <a:ea typeface="Microsoft YaHei" pitchFamily="34" charset="-122"/>
                 <a:cs typeface="Microsoft YaHei" pitchFamily="34" charset="-120"/>
               </a:rPr>
-              <a:t>metrics now record inference_date</a:t>
+              <a:t>metrics 记录 inference_date</a:t>
             </a:r>
             <a:endParaRPr lang="en-US" sz="800" dirty="0"/>
           </a:p>
@@ -16568,7 +16568,7 @@
                   <a:srgbClr val="94A3B8"/>
                 </a:solidFill>
               </a:rPr>
-              <a:t>2026-05-07 · CSI300 Competition Review</a:t>
+              <a:t>2026-05-07 · CSI300 比赛复盘</a:t>
             </a:r>
             <a:endParaRPr lang="en-US" sz="750" dirty="0"/>
           </a:p>
@@ -17376,7 +17376,7 @@
                 <a:ea typeface="Microsoft YaHei" pitchFamily="34" charset="-122"/>
                 <a:cs typeface="Microsoft YaHei" pitchFamily="34" charset="-120"/>
               </a:rPr>
-              <a:t>RESULTS</a:t>
+              <a:t>结果</a:t>
             </a:r>
             <a:endParaRPr lang="en-US" sz="800" dirty="0"/>
           </a:p>
@@ -17476,7 +17476,7 @@
                   <a:srgbClr val="94A3B8"/>
                 </a:solidFill>
               </a:rPr>
-              <a:t>2026-05-07 · CSI300 Competition Review</a:t>
+              <a:t>2026-05-07 · CSI300 比赛复盘</a:t>
             </a:r>
             <a:endParaRPr lang="en-US" sz="750" dirty="0"/>
           </a:p>
@@ -17529,7 +17529,7 @@
                           <a:ea typeface="Microsoft YaHei" pitchFamily="34" charset="-122"/>
                           <a:cs typeface="Microsoft YaHei" pitchFamily="34" charset="-120"/>
                         </a:rPr>
-                        <a:t>Method</a:t>
+                        <a:t>方法</a:t>
                       </a:r>
                       <a:endParaRPr lang="en-US" sz="820" dirty="0">
                         <a:latin typeface="Microsoft YaHei" charset="0"/>
@@ -17597,7 +17597,7 @@
                           <a:ea typeface="Microsoft YaHei" pitchFamily="34" charset="-122"/>
                           <a:cs typeface="Microsoft YaHei" pitchFamily="34" charset="-120"/>
                         </a:rPr>
-                        <a:t>Strategy</a:t>
+                        <a:t>策略</a:t>
                       </a:r>
                       <a:endParaRPr lang="en-US" sz="820" dirty="0">
                         <a:latin typeface="Microsoft YaHei" charset="0"/>
@@ -20242,7 +20242,7 @@
                 <a:ea typeface="Microsoft YaHei" pitchFamily="34" charset="-122"/>
                 <a:cs typeface="Microsoft YaHei" pitchFamily="34" charset="-120"/>
               </a:rPr>
-              <a:t>RISK REVIEW</a:t>
+              <a:t>风险审查</a:t>
             </a:r>
             <a:endParaRPr lang="en-US" sz="800" dirty="0"/>
           </a:p>
@@ -20342,7 +20342,7 @@
                   <a:srgbClr val="94A3B8"/>
                 </a:solidFill>
               </a:rPr>
-              <a:t>2026-05-07 · CSI300 Competition Review</a:t>
+              <a:t>2026-05-07 · CSI300 比赛复盘</a:t>
             </a:r>
             <a:endParaRPr lang="en-US" sz="750" dirty="0"/>
           </a:p>
@@ -20588,7 +20588,7 @@
                 <a:ea typeface="Microsoft YaHei" pitchFamily="34" charset="-122"/>
                 <a:cs typeface="Microsoft YaHei" pitchFamily="34" charset="-120"/>
               </a:rPr>
-              <a:t>negative days</a:t>
+              <a:t>负收益日比例</a:t>
             </a:r>
             <a:endParaRPr lang="en-US" sz="850" dirty="0"/>
           </a:p>
@@ -20670,7 +20670,7 @@
                 <a:ea typeface="Microsoft YaHei" pitchFamily="34" charset="-122"/>
                 <a:cs typeface="Microsoft YaHei" pitchFamily="34" charset="-120"/>
               </a:rPr>
-              <a:t>worst day</a:t>
+              <a:t>最差单日</a:t>
             </a:r>
             <a:endParaRPr lang="en-US" sz="850" dirty="0"/>
           </a:p>
@@ -20842,7 +20842,7 @@
                           <a:ea typeface="Microsoft YaHei" pitchFamily="34" charset="-122"/>
                           <a:cs typeface="Microsoft YaHei" pitchFamily="34" charset="-120"/>
                         </a:rPr>
-                        <a:t>Policy</a:t>
+                        <a:t>策略</a:t>
                       </a:r>
                       <a:endParaRPr lang="en-US" sz="820" dirty="0">
                         <a:latin typeface="Microsoft YaHei" charset="0"/>
@@ -20978,7 +20978,7 @@
                           <a:ea typeface="Microsoft YaHei" pitchFamily="34" charset="-122"/>
                           <a:cs typeface="Microsoft YaHei" pitchFamily="34" charset="-120"/>
                         </a:rPr>
-                        <a:t>Role</a:t>
+                        <a:t>定位</a:t>
                       </a:r>
                       <a:endParaRPr lang="en-US" sz="820" dirty="0">
                         <a:latin typeface="Microsoft YaHei" charset="0"/>
@@ -21184,7 +21184,7 @@
                           <a:ea typeface="Microsoft YaHei" pitchFamily="34" charset="-122"/>
                           <a:cs typeface="Microsoft YaHei" pitchFamily="34" charset="-120"/>
                         </a:rPr>
-                        <a:t>aggressive</a:t>
+                        <a:t>冲榜</a:t>
                       </a:r>
                       <a:endParaRPr lang="en-US" sz="820" dirty="0">
                         <a:latin typeface="Microsoft YaHei" charset="0"/>
@@ -21390,7 +21390,7 @@
                           <a:ea typeface="Microsoft YaHei" pitchFamily="34" charset="-122"/>
                           <a:cs typeface="Microsoft YaHei" pitchFamily="34" charset="-120"/>
                         </a:rPr>
-                        <a:t>balanced</a:t>
+                        <a:t>折中</a:t>
                       </a:r>
                       <a:endParaRPr lang="en-US" sz="820" dirty="0">
                         <a:latin typeface="Microsoft YaHei" charset="0"/>
@@ -21596,7 +21596,7 @@
                           <a:ea typeface="Microsoft YaHei" pitchFamily="34" charset="-122"/>
                           <a:cs typeface="Microsoft YaHei" pitchFamily="34" charset="-120"/>
                         </a:rPr>
-                        <a:t>fallback</a:t>
+                        <a:t>兜底</a:t>
                       </a:r>
                       <a:endParaRPr lang="en-US" sz="820" dirty="0">
                         <a:latin typeface="Microsoft YaHei" charset="0"/>
@@ -21717,7 +21717,7 @@
                 <a:ea typeface="Microsoft YaHei" pitchFamily="34" charset="-122"/>
                 <a:cs typeface="Microsoft YaHei" pitchFamily="34" charset="-120"/>
               </a:rPr>
-              <a:t>OBJECTIVE REVIEW</a:t>
+              <a:t>目标审查</a:t>
             </a:r>
             <a:endParaRPr lang="en-US" sz="800" dirty="0"/>
           </a:p>
@@ -21817,7 +21817,7 @@
                   <a:srgbClr val="94A3B8"/>
                 </a:solidFill>
               </a:rPr>
-              <a:t>2026-05-07 · CSI300 Competition Review</a:t>
+              <a:t>2026-05-07 · CSI300 比赛复盘</a:t>
             </a:r>
             <a:endParaRPr lang="en-US" sz="750" dirty="0"/>
           </a:p>
@@ -22015,7 +22015,7 @@
                           <a:ea typeface="Microsoft YaHei" pitchFamily="34" charset="-122"/>
                           <a:cs typeface="Microsoft YaHei" pitchFamily="34" charset="-120"/>
                         </a:rPr>
-                        <a:t>Method</a:t>
+                        <a:t>方法</a:t>
                       </a:r>
                       <a:endParaRPr lang="en-US" sz="820" dirty="0">
                         <a:latin typeface="Microsoft YaHei" charset="0"/>
@@ -22083,7 +22083,7 @@
                           <a:ea typeface="Microsoft YaHei" pitchFamily="34" charset="-122"/>
                           <a:cs typeface="Microsoft YaHei" pitchFamily="34" charset="-120"/>
                         </a:rPr>
-                        <a:t>Strategy</a:t>
+                        <a:t>策略</a:t>
                       </a:r>
                       <a:endParaRPr lang="en-US" sz="820" dirty="0">
                         <a:latin typeface="Microsoft YaHei" charset="0"/>
@@ -23244,7 +23244,7 @@
                 <a:ea typeface="Microsoft YaHei" pitchFamily="34" charset="-122"/>
                 <a:cs typeface="Microsoft YaHei" pitchFamily="34" charset="-120"/>
               </a:rPr>
-              <a:t>LIMITATIONS</a:t>
+              <a:t>局限性</a:t>
             </a:r>
             <a:endParaRPr lang="en-US" sz="800" dirty="0"/>
           </a:p>
@@ -23285,7 +23285,7 @@
                 <a:ea typeface="Microsoft YaHei" pitchFamily="34" charset="-122"/>
                 <a:cs typeface="Microsoft YaHei" pitchFamily="34" charset="-120"/>
               </a:rPr>
-              <a:t>局限性：现在最需要 code review 的地方</a:t>
+              <a:t>局限性：现在最需要代码审查的地方</a:t>
             </a:r>
             <a:endParaRPr lang="en-US" sz="2400" dirty="0"/>
           </a:p>
@@ -23344,7 +23344,7 @@
                   <a:srgbClr val="94A3B8"/>
                 </a:solidFill>
               </a:rPr>
-              <a:t>2026-05-07 · CSI300 Competition Review</a:t>
+              <a:t>2026-05-07 · CSI300 比赛复盘</a:t>
             </a:r>
             <a:endParaRPr lang="en-US" sz="750" dirty="0"/>
           </a:p>
@@ -23930,7 +23930,7 @@
                 <a:ea typeface="Microsoft YaHei" pitchFamily="34" charset="-122"/>
                 <a:cs typeface="Microsoft YaHei" pitchFamily="34" charset="-120"/>
               </a:rPr>
-              <a:t>Review stance</a:t>
+              <a:t>审查立场</a:t>
             </a:r>
             <a:endParaRPr lang="en-US" sz="950" dirty="0"/>
           </a:p>

</xml_diff>